<commit_message>
v2 final: dual-teacher + sweep + GLM third judge, verified reasons
- Both teachers now cover 5,500 candidates (3,000 rule shortlist + 2,500
  recall-rescue sweep); sweep rescued 9 tier-4 gems the rules under-ranked
- GLM-5.2 third judge on the top-100 (Kimi emits empty output on Nebius);
  top-10 is unanimous tier-5 across three model families
- active_before_signup check removed: fires on 7,496 profiles = generator
  noise, not a trap signature (precision over recall for honeypot flags)
- reasons_final.jsonl: rank-toned, fact-verified reasoning for the final 100
- orjson fast-path; selftest wall ~190-265s / 0.21GB, inside spec limits
- gitignore: whitelist all artifacts needed for Stage-3 reproduction
</commit_message>
<xml_diff>
--- a/deck/parakh_deck.pptx
+++ b/deck/parakh_deck.pptx
@@ -4703,7 +4703,7 @@
                 </a:solidFill>
                 <a:latin typeface="Cambria"/>
               </a:rPr>
-              <a:t>Two independent judges — the top is where they agree</a:t>
+              <a:t>Three model families — the top is where they agree</a:t>
             </a:r>
           </a:p>
         </p:txBody>
@@ -4782,13 +4782,13 @@
               </a:spcAft>
             </a:pPr>
             <a:r>
-              <a:rPr sz="1800" b="1" i="0">
+              <a:rPr sz="1700" b="1" i="0">
                 <a:solidFill>
                   <a:srgbClr val="1B2A41"/>
                 </a:solidFill>
                 <a:latin typeface="Cambria"/>
               </a:rPr>
-              <a:t>DeepSeek-V4</a:t>
+              <a:t>DeepSeek + Qwen</a:t>
             </a:r>
           </a:p>
           <a:p>
@@ -4807,7 +4807,7 @@
                 </a:solidFill>
                 <a:latin typeface="Calibri"/>
               </a:rPr>
-              <a:t>primary teacher</a:t>
+              <a:t>two independent teachers</a:t>
             </a:r>
           </a:p>
         </p:txBody>
@@ -4892,7 +4892,7 @@
                 </a:solidFill>
                 <a:latin typeface="Cambria"/>
               </a:rPr>
-              <a:t>Kimi-K2.6</a:t>
+              <a:t>GLM-5.2</a:t>
             </a:r>
           </a:p>
           <a:p>
@@ -4911,7 +4911,7 @@
                 </a:solidFill>
                 <a:latin typeface="Calibri"/>
               </a:rPr>
-              <a:t>independent 2nd judge</a:t>
+              <a:t>3rd judge — contested top</a:t>
             </a:r>
           </a:p>
         </p:txBody>
@@ -5105,7 +5105,7 @@
                 </a:solidFill>
                 <a:latin typeface="Calibri"/>
               </a:rPr>
-              <a:t>both</a:t>
+              <a:t>every model family</a:t>
             </a:r>
             <a:r>
               <a:rPr sz="1350" b="0" i="0">
@@ -5114,7 +5114,7 @@
                 </a:solidFill>
                 <a:latin typeface="Calibri"/>
               </a:rPr>
-              <a:t> rate tier-5 rise to the very top.</a:t>
+              <a:t> endorses rise to the very top.</a:t>
             </a:r>
           </a:p>
         </p:txBody>
@@ -6560,7 +6560,7 @@
                 </a:solidFill>
                 <a:latin typeface="Cambria"/>
               </a:rPr>
-              <a:t>DeepSeek-V4</a:t>
+              <a:t>DeepSeek + Qwen</a:t>
             </a:r>
           </a:p>
         </p:txBody>
@@ -6599,7 +6599,7 @@
                 </a:solidFill>
                 <a:latin typeface="Calibri"/>
               </a:rPr>
-              <a:t>teacher — grades 3,000</a:t>
+              <a:t>two teachers — 5,500 graded each</a:t>
             </a:r>
           </a:p>
         </p:txBody>
@@ -6772,7 +6772,7 @@
                 </a:solidFill>
                 <a:latin typeface="Cambria"/>
               </a:rPr>
-              <a:t>Kimi-K2.6</a:t>
+              <a:t>GLM-5.2</a:t>
             </a:r>
           </a:p>
         </p:txBody>
@@ -6811,7 +6811,7 @@
                 </a:solidFill>
                 <a:latin typeface="Calibri"/>
               </a:rPr>
-              <a:t>2nd judge — top 100</a:t>
+              <a:t>3rd judge — contested top</a:t>
             </a:r>
           </a:p>
         </p:txBody>
@@ -7855,7 +7855,7 @@
                 </a:solidFill>
                 <a:latin typeface="Calibri"/>
               </a:rPr>
-              <a:t>top-10 are tier-5 by both judges</a:t>
+              <a:t>top-10 rated tier-5 by three model families</a:t>
             </a:r>
           </a:p>
         </p:txBody>
@@ -13541,7 +13541,7 @@
                 </a:solidFill>
                 <a:latin typeface="Calibri"/>
               </a:rPr>
-              <a:t>A frontier LLM (DeepSeek-V4) grades the plausible candidates on the job rubric. Slow, brilliant, unconstrained.</a:t>
+              <a:t>Two frontier LLMs (DeepSeek-V4, Qwen-235B) grade every plausible candidate on the job rubric. Slow, brilliant, unconstrained.</a:t>
             </a:r>
           </a:p>
         </p:txBody>
@@ -14346,7 +14346,8 @@
                 </a:solidFill>
                 <a:latin typeface="Calibri"/>
               </a:rPr>
-              <a:t>Embed + features</a:t>
+              <a:t>Sweep all 100k
++ features</a:t>
             </a:r>
           </a:p>
         </p:txBody>
@@ -14475,8 +14476,8 @@
                 </a:solidFill>
                 <a:latin typeface="Calibri"/>
               </a:rPr>
-              <a:t>DeepSeek-V4
-grades fit 0–5</a:t>
+              <a:t>DeepSeek-V4 + Qwen-235B
+grade fit 0–5</a:t>
             </a:r>
           </a:p>
         </p:txBody>
@@ -14605,8 +14606,8 @@
                 </a:solidFill>
                 <a:latin typeface="Calibri"/>
               </a:rPr>
-              <a:t>Kimi-K2.6
-2nd judge</a:t>
+              <a:t>GLM-5.2
+3rd judge</a:t>
             </a:r>
           </a:p>
         </p:txBody>

</xml_diff>